<commit_message>
Refine documentation language and embed UI screenshots
</commit_message>
<xml_diff>
--- a/OmniGesture_Pitch.pptx
+++ b/OmniGesture_Pitch.pptx
@@ -5649,7 +5649,7 @@
         </p:nvSpPr>
         <p:spPr>
           <a:xfrm>
-            <a:off x="1371600" y="1828800"/>
+            <a:off x="18288000" y="18288000"/>
             <a:ext cx="4114800" cy="457200"/>
           </a:xfrm>
           <a:prstGeom prst="rect">
@@ -5685,7 +5685,7 @@
         </p:nvSpPr>
         <p:spPr>
           <a:xfrm>
-            <a:off x="1371600" y="2377440"/>
+            <a:off x="18288000" y="18288000"/>
             <a:ext cx="4114800" cy="3200400"/>
           </a:xfrm>
           <a:prstGeom prst="rect">
@@ -5730,7 +5730,7 @@
         </p:nvSpPr>
         <p:spPr>
           <a:xfrm>
-            <a:off x="1828800" y="3474720"/>
+            <a:off x="18288000" y="18288000"/>
             <a:ext cx="3200400" cy="457200"/>
           </a:xfrm>
           <a:prstGeom prst="rect">
@@ -5766,7 +5766,7 @@
         </p:nvSpPr>
         <p:spPr>
           <a:xfrm>
-            <a:off x="6400800" y="1828800"/>
+            <a:off x="18288000" y="18288000"/>
             <a:ext cx="4114800" cy="457200"/>
           </a:xfrm>
           <a:prstGeom prst="rect">
@@ -5802,7 +5802,7 @@
         </p:nvSpPr>
         <p:spPr>
           <a:xfrm>
-            <a:off x="6400800" y="2377440"/>
+            <a:off x="18288000" y="18288000"/>
             <a:ext cx="4114800" cy="3200400"/>
           </a:xfrm>
           <a:prstGeom prst="rect">
@@ -5847,7 +5847,7 @@
         </p:nvSpPr>
         <p:spPr>
           <a:xfrm>
-            <a:off x="6858000" y="3474720"/>
+            <a:off x="18288000" y="18288000"/>
             <a:ext cx="3200400" cy="457200"/>
           </a:xfrm>
           <a:prstGeom prst="rect">
@@ -5883,7 +5883,7 @@
         </p:nvSpPr>
         <p:spPr>
           <a:xfrm>
-            <a:off x="731520" y="5943600"/>
+            <a:off x="18288000" y="18288000"/>
             <a:ext cx="10058400" cy="457200"/>
           </a:xfrm>
           <a:prstGeom prst="rect">
@@ -5911,6 +5911,30 @@
           </a:p>
         </p:txBody>
       </p:sp>
+      <p:pic>
+        <p:nvPicPr>
+          <p:cNvPr id="10" name="Picture 9" descr="media_1790613616415.png"/>
+          <p:cNvPicPr>
+            <a:picLocks noChangeAspect="1"/>
+          </p:cNvPicPr>
+          <p:nvPr/>
+        </p:nvPicPr>
+        <p:blipFill>
+          <a:blip r:embed="rId2"/>
+          <a:stretch>
+            <a:fillRect/>
+          </a:stretch>
+        </p:blipFill>
+        <p:spPr>
+          <a:xfrm>
+            <a:off x="1371600" y="1371600"/>
+            <a:ext cx="9445752" cy="5018056"/>
+          </a:xfrm>
+          <a:prstGeom prst="rect">
+            <a:avLst/>
+          </a:prstGeom>
+        </p:spPr>
+      </p:pic>
     </p:spTree>
   </p:cSld>
   <p:clrMapOvr>

</xml_diff>